<commit_message>
Batch 13.6: executed notebook (Kaggle T4, 27.9 min, 0 errors, live = cache exactly incl. SAM chain), write-up System paragraph, updated slides PPTX
</commit_message>
<xml_diff>
--- a/slides/20260876_MarlenMelis_slides.pptx
+++ b/slides/20260876_MarlenMelis_slides.pptx
@@ -596,7 +596,7 @@
           <a:p>
             <a:r>
               <a:rPr lang="en-US" dirty="0"/>
-              <a:t>In August 2022 Seoul had 141.5 millimetres of rain in one hour, the most since 1907, and Gangnam's streets became rivers. In July 2023 the Osong underpass flooded in minutes and 14 people died. In the first hours, rescue coordinators need one answer per street and per house: can a truck get there, does it need a boat, or is it cut off? Drones deliver photos fast, but labelling one photo takes about an hour, and a normal segmentation model needs over a thousand labelled photos. So my question was: how far do 50 labelled photos get us, and is that map good enough to route rescue teams? The short answer is on the right: .472 mIoU on the whole FloodNet test set, a router that finds cut-off houses with F1 .759, and when the system says "confident: truck", it is right 98.7 percent of the time. Fully supervised PSPNet gets .848, so this is a fast first map, not a replacement.</a:t>
+              <a:t>In August 2022 Seoul had 141.5 millimetres of rain in one hour, the most since 1907, and Gangnam's streets became rivers. In July 2023 the Osong underpass flooded in minutes and 14 people died. In the first hours, rescue coordinators need one answer per street and per house: can a truck get there, does it need a boat, or is it cut off? Drones deliver photos fast, but labelling one photo takes about an hour, and a normal segmentation model needs over a thousand labelled photos. So my question was: how far do 50 labelled photos get us, and is that map good enough to route rescue teams? The short answer is on the right: .507 mIoU on the whole FloodNet test set, a router that finds cut-off houses with F1 .752, and when the system says "confident: truck", it was right for all 208 such houses in the test photos. Fully supervised PSPNet gets .848, so this is a fast first map, not a replacement.</a:t>
             </a:r>
             <a:endParaRPr lang="en-US" dirty="0"/>
           </a:p>
@@ -772,7 +772,7 @@
           <a:p>
             <a:r>
               <a:rPr lang="en-US" dirty="0"/>
-              <a:t>Data: FloodNet, from Hurricane Harvey, for the main experiments — I adapt on 1, 5, 10, 20 or 50 labelled photos, tune on 30, and test on all 448 test photos. RescueNet, from Hurricane Michael, is the second disaster. I did not label anything myself; every label is the dataset's own. The only pretrained weights are the course's Chameleon checkpoint; fine-tuning only touches the biases, the matching temperature and one LayerNorm, so each model is five megabytes. Same recipe for every run, sized to fit a free 16-gigabyte T4: 384-pixel crops, batch 2, Adam with a cosine schedule, half precision. Seven runs, about 17 GPU-hours on Kaggle. And the final notebook reruns on a fresh T4 in 26 minutes, with live predictions identical to the stored ones.</a:t>
+              <a:t>Data: FloodNet, from Hurricane Harvey, for the main experiments — I adapt on 1, 5, 10, 20 or 50 labelled photos, tune on 30, and test on all 448 test photos. RescueNet, from Hurricane Michael, is the second disaster. I did not label anything myself; every label is the dataset's own. The main pretrained weights are the course's Chameleon checkpoint, plus SAM to redraw building outlines; fine-tuning only touches the biases, the matching temperature and one LayerNorm, so each model is five megabytes. Same recipe for every run, sized to fit a free 16-gigabyte T4: 384-pixel crops, batch 2, Adam with a cosine schedule, half precision. Seven runs plus 21 improvement runs, about 29 GPU-hours on Kaggle. And the final notebook reruns on a fresh T4 in about 28 minutes. On Kaggle, where the stored predictions were made, the live ones are identical; on Colab, 99.99 percent of pixels come out the same.</a:t>
             </a:r>
             <a:endParaRPr lang="en-US" dirty="0"/>
           </a:p>
@@ -860,7 +860,7 @@
           <a:p>
             <a:r>
               <a:rPr lang="en-US" dirty="0"/>
-              <a:t>Track A results. The curve shows mIoU against the number of labelled photos, with 95 percent bootstrap intervals. From one to five photos the gain is real, plus .14. Between five and ten I could not measure any gain, and from 20 to 50 it jumps again by .10. On the full test set the 50-shot model reaches .472. The dashed line is PSPNet, trained on all 1,445 labelled photos: .848. Most of the gap is flooded roads: .29 against .82 — shallow brown water and a dry road look very similar from above. And transfer: the FloodNet model applied to a different hurricane with zero new labels gets .32 on roads, buildings and water; with just 20 labels from the new disaster it gets .63. So every new disaster needs a few of its own labels — which is exactly the few-shot setting.</a:t>
+              <a:t>Track A results. The curve shows mIoU against the number of labelled photos, with 95 percent bootstrap intervals. From one to five photos the gain is real, plus .14. Between five and ten I could not measure any gain, and from 20 to 50 it jumps again by .10. On the full test set the final 50-shot model reaches .507, up from .472 for my first model after a round of 36 tested improvements. The dashed line is PSPNet, trained on all 1,445 labelled photos: .848. Most of the gap is flooded roads: .31 against .82 — shallow brown water and a dry road look very similar from above. And transfer: the FloodNet model applied to a different hurricane with zero new labels gets .32 on roads, buildings and water; with just 20 labels from the new disaster it gets .63. So every new disaster needs a few of its own labels — which is exactly the few-shot setting.</a:t>
             </a:r>
             <a:endParaRPr lang="en-US" dirty="0"/>
           </a:p>
@@ -948,7 +948,7 @@
           <a:p>
             <a:r>
               <a:rPr lang="en-US" dirty="0"/>
-              <a:t>Track B is the system around the map. The router finds the cheapest way from the entry point to every house: truck on clear roads, then a boat across water, then on foot — with vehicle widths, parked cars and tree canopy taken into account. Left is the predicted map, middle the same street routed on the human labels — the same house needs a boat on both. Right, the hurricane-Michael canal: truck to the canal, boat across, walk to the house. Against the labelled map the router finds the houses that are cut off by road with F1 .759 on the full test. And it says how sure it is: houses marked "confident: truck" are right 98.7 percent of the time; "check first" only 74 percent. Everything runs in a web map of all 200 test photos, and a Gradio app runs the model live on an uploaded photo in 16 seconds. [Live demo here if there is time.]</a:t>
+              <a:t>Track B is the system around the map. The router finds the cheapest way from the entry point to every house: truck on clear roads, then a boat across water, then on foot — with vehicle widths, parked cars and tree canopy taken into account. Left is the predicted map, middle the same street routed on the human labels — the same house needs a boat on both. Right, the hurricane-Michael canal: truck to the canal, boat across, walk to the house. Against the labelled map the router finds the houses that are cut off by road with F1 .752 on the full test; the better map did not change routing measurably. And it says how sure it is: houses marked "confident: truck" were all right; "check first" 79 percent. Everything runs in a web map of all 200 test photos, and a Gradio app runs the model live on an uploaded photo in 30 seconds. [Live demo here if there is time.]</a:t>
             </a:r>
             <a:endParaRPr lang="en-US" dirty="0"/>
           </a:p>
@@ -1036,7 +1036,7 @@
           <a:p>
             <a:r>
               <a:rPr lang="en-US" dirty="0"/>
-              <a:t>What I learned. The most dangerous mistake is shallow water read as dry land: the map then invites a truck into water. Here is that failure, honestly: the model thought this flooded street was land. But the six houses it wrongly calls truck-reachable are all flagged "check first", because the system routes every map twice, once cautiously. A simple rule from the failure analysis — no off-road driving where the water probability is high — raised the cut-off F1 from .74 to .84. So: saying how sure we are matters more than a few IoU points. Things I tried and dropped: test-time flips, which looked good on the tuning photos but lost on the test set; more labels between 5 and 10, which gave nothing measurable; and smoothing. Limits: these are US hurricanes, not Korean city floods; single photos without GPS; and the labelled map is my router on human labels, not field-checked access. Thank you.</a:t>
+              <a:t>What I learned. The most dangerous mistake is shallow water read as dry land: the map then invites a truck into water. Here is that failure, honestly: the model thought this flooded street was land. But the six houses it wrongly calls truck-reachable are all flagged "check first", because the system routes every map twice, once cautiously. A simple rule from the failure analysis — no off-road driving where the water probability is high — raised the cut-off F1 from .74 to .84. So: saying how sure we are matters more than a few IoU points. I also tried 36 improvement ideas on the 50-shot model, each judged only on the 30 tuning photos. Four survived: a shorter training schedule, averaging two snapshots, an edge-aware decode, and SAM to redraw building outlines; together .472 to .507 on the test set. Most others lost, for example pseudo-labels and rare-class losses, and test-time flips looked good on the tuning photos but lost on the test set. Limits: these are US hurricanes, not Korean city floods; single photos without GPS; and the labelled map is my router on human labels, not field-checked access. Thank you.</a:t>
             </a:r>
             <a:endParaRPr lang="en-US" dirty="0"/>
           </a:p>
@@ -1693,6 +1693,10 @@
           </a:gradFill>
           <a:ln/>
         </p:spPr>
+        <p:txBody>
+          <a:bodyPr/>
+          <a:p/>
+        </p:txBody>
       </p:sp>
       <p:sp>
         <p:nvSpPr>
@@ -2244,6 +2248,10 @@
             <a:prstDash val="solid"/>
           </a:ln>
         </p:spPr>
+        <p:txBody>
+          <a:bodyPr/>
+          <a:p/>
+        </p:txBody>
       </p:sp>
       <p:sp>
         <p:nvSpPr>
@@ -2283,7 +2291,7 @@
                 <a:ea typeface="Rubik" pitchFamily="34" charset="-122"/>
                 <a:cs typeface="Rubik" pitchFamily="34" charset="-120"/>
               </a:rPr>
-              <a:t>.472 mIoU</a:t>
+              <a:t>.507 mIoU</a:t>
             </a:r>
             <a:endParaRPr lang="en-US" sz="3600" dirty="0"/>
           </a:p>
@@ -2359,6 +2367,10 @@
             <a:prstDash val="solid"/>
           </a:ln>
         </p:spPr>
+        <p:txBody>
+          <a:bodyPr/>
+          <a:p/>
+        </p:txBody>
       </p:sp>
       <p:sp>
         <p:nvSpPr>
@@ -2398,7 +2410,7 @@
                 <a:ea typeface="Rubik" pitchFamily="34" charset="-122"/>
                 <a:cs typeface="Rubik" pitchFamily="34" charset="-120"/>
               </a:rPr>
-              <a:t>.759 F1</a:t>
+              <a:t>.752 F1</a:t>
             </a:r>
             <a:endParaRPr lang="en-US" sz="3600" dirty="0"/>
           </a:p>
@@ -2474,6 +2486,10 @@
             <a:prstDash val="solid"/>
           </a:ln>
         </p:spPr>
+        <p:txBody>
+          <a:bodyPr/>
+          <a:p/>
+        </p:txBody>
       </p:sp>
       <p:sp>
         <p:nvSpPr>
@@ -2513,7 +2529,7 @@
                 <a:ea typeface="Rubik" pitchFamily="34" charset="-122"/>
                 <a:cs typeface="Rubik" pitchFamily="34" charset="-120"/>
               </a:rPr>
-              <a:t>98.7 %</a:t>
+              <a:t>100 %</a:t>
             </a:r>
             <a:endParaRPr lang="en-US" sz="3600" dirty="0"/>
           </a:p>
@@ -4500,6 +4516,10 @@
             <a:prstDash val="solid"/>
           </a:ln>
         </p:spPr>
+        <p:txBody>
+          <a:bodyPr/>
+          <a:p/>
+        </p:txBody>
       </p:sp>
       <p:sp>
         <p:nvSpPr>
@@ -4725,6 +4745,10 @@
             <a:prstDash val="solid"/>
           </a:ln>
         </p:spPr>
+        <p:txBody>
+          <a:bodyPr/>
+          <a:p/>
+        </p:txBody>
       </p:sp>
       <p:sp>
         <p:nvSpPr>
@@ -4874,7 +4898,7 @@
                 <a:ea typeface="IBM Plex Sans" pitchFamily="34" charset="-122"/>
                 <a:cs typeface="IBM Plex Sans" pitchFamily="34" charset="-120"/>
               </a:rPr>
-              <a:t>Fine-tuned: biases, matching temperature, one LayerNorm: 5 MB per model. No other pretrained model.</a:t>
+              <a:t>Fine-tuned: biases, temperature, one LayerNorm (5 MB per model). Plus SAM to redraw building outlines.</a:t>
             </a:r>
             <a:endParaRPr lang="en-US" sz="1400" dirty="0"/>
           </a:p>
@@ -4906,6 +4930,10 @@
             <a:prstDash val="solid"/>
           </a:ln>
         </p:spPr>
+        <p:txBody>
+          <a:bodyPr/>
+          <a:p/>
+        </p:txBody>
       </p:sp>
       <p:sp>
         <p:nvSpPr>
@@ -5033,7 +5061,7 @@
                 <a:ea typeface="IBM Plex Sans" pitchFamily="34" charset="-122"/>
                 <a:cs typeface="IBM Plex Sans" pitchFamily="34" charset="-120"/>
               </a:rPr>
-              <a:t>7 runs on free Kaggle T4 GPUs, about 17 GPU-hours.</a:t>
+              <a:t>28 runs on free Kaggle T4 GPUs, about 29 GPU-hours.</a:t>
             </a:r>
             <a:endParaRPr lang="en-US" sz="1400" dirty="0"/>
           </a:p>
@@ -5077,7 +5105,7 @@
                 <a:ea typeface="IBM Plex Sans" pitchFamily="34" charset="-122"/>
                 <a:cs typeface="IBM Plex Sans" pitchFamily="34" charset="-120"/>
               </a:rPr>
-              <a:t>The notebook reruns everything on a fresh T4 in 26 minutes, and its live 50-shot predictions match the stored ones </a:t>
+              <a:t>The notebook reruns everything on a fresh T4 in about 28 minutes; its live 50-shot predictions match the stored ones </a:t>
             </a:r>
             <a:r>
               <a:rPr lang="en-US" sz="1600" b="1" dirty="0">
@@ -5088,7 +5116,7 @@
                 <a:ea typeface="IBM Plex Sans" pitchFamily="34" charset="-122"/>
                 <a:cs typeface="IBM Plex Sans" pitchFamily="34" charset="-120"/>
               </a:rPr>
-              <a:t>bit for bit</a:t>
+              <a:t>exactly on Kaggle</a:t>
             </a:r>
             <a:r>
               <a:rPr lang="en-US" sz="1600" dirty="0">
@@ -5099,7 +5127,7 @@
                 <a:ea typeface="IBM Plex Sans" pitchFamily="34" charset="-122"/>
                 <a:cs typeface="IBM Plex Sans" pitchFamily="34" charset="-120"/>
               </a:rPr>
-              <a:t>.</a:t>
+              <a:t> and on 99.99 % of pixels on Colab.</a:t>
             </a:r>
             <a:endParaRPr lang="en-US" sz="1600" dirty="0"/>
           </a:p>
@@ -5273,7 +5301,7 @@
       </p:sp>
       <p:pic>
         <p:nvPicPr>
-          <p:cNvPr id="3" name="Image 0" descr="Learning curve: mIoU on 100 test photos rises from 0.26 with 1 labelled photo to 0.49 with 50 (tuned decode), with 95 percent intervals; full test 0.472; PSPNet with 1,445 labels at 0.848">    </p:cNvPr>
+          <p:cNvPr id="3" name="Image 0" descr="Learning curve: mIoU on 100 test photos rises from 0.26 with 1 labelled photo to 0.52 with 50 (final model, tuned decode), with 95 percent intervals; full test 0.507 (first model 0.472); PSPNet with 1,445 labels at 0.848">    </p:cNvPr>
           <p:cNvPicPr>
             <a:picLocks noChangeAspect="1"/>
           </p:cNvPicPr>
@@ -5442,7 +5470,7 @@
                 <a:ea typeface="IBM Plex Sans" pitchFamily="34" charset="-122"/>
                 <a:cs typeface="IBM Plex Sans" pitchFamily="34" charset="-120"/>
               </a:rPr>
-              <a:t>Flooded roads are the gap:</a:t>
+              <a:t>Flooded roads are the gap: IoU .31 vs .82 for PSPNet. Water and dry roads look alike from above.</a:t>
             </a:r>
             <a:r>
               <a:rPr lang="en-US" sz="1500" dirty="0">
@@ -5453,7 +5481,7 @@
                 <a:ea typeface="IBM Plex Sans" pitchFamily="34" charset="-122"/>
                 <a:cs typeface="IBM Plex Sans" pitchFamily="34" charset="-120"/>
               </a:rPr>
-              <a:t> IoU .29 vs .82 for PSPNet. Water and dry roads look alike from above.</a:t>
+              <a:t/>
             </a:r>
             <a:endParaRPr lang="en-US" sz="1500" dirty="0"/>
           </a:p>
@@ -5909,6 +5937,10 @@
             <a:prstDash val="solid"/>
           </a:ln>
         </p:spPr>
+        <p:txBody>
+          <a:bodyPr/>
+          <a:p/>
+        </p:txBody>
       </p:sp>
       <p:sp>
         <p:nvSpPr>
@@ -5959,7 +5991,7 @@
                 <a:ea typeface="IBM Plex Sans" pitchFamily="34" charset="-122"/>
                 <a:cs typeface="IBM Plex Sans" pitchFamily="34" charset="-120"/>
               </a:rPr>
-              <a:t> F1 .759 on 1,232 test houses (.835 on the 100-photo set, .818 RescueNet)</a:t>
+              <a:t> F1 .752 on 1,232 test houses (.819 on the 100-photo set, .818 RescueNet)</a:t>
             </a:r>
             <a:endParaRPr lang="en-US" sz="1400" dirty="0"/>
           </a:p>
@@ -5987,6 +6019,10 @@
             <a:prstDash val="solid"/>
           </a:ln>
         </p:spPr>
+        <p:txBody>
+          <a:bodyPr/>
+          <a:p/>
+        </p:txBody>
       </p:sp>
       <p:sp>
         <p:nvSpPr>
@@ -6037,7 +6073,7 @@
                 <a:ea typeface="IBM Plex Sans" pitchFamily="34" charset="-122"/>
                 <a:cs typeface="IBM Plex Sans" pitchFamily="34" charset="-120"/>
               </a:rPr>
-              <a:t> “confident: truck” is right 98.7 %, “check first” only 74 %</a:t>
+              <a:t> “confident: truck” is right 100 %, “check first” 79 %</a:t>
             </a:r>
             <a:endParaRPr lang="en-US" sz="1400" dirty="0"/>
           </a:p>
@@ -6065,6 +6101,10 @@
             <a:prstDash val="solid"/>
           </a:ln>
         </p:spPr>
+        <p:txBody>
+          <a:bodyPr/>
+          <a:p/>
+        </p:txBody>
       </p:sp>
       <p:sp>
         <p:nvSpPr>
@@ -6115,7 +6155,7 @@
                 <a:ea typeface="IBM Plex Sans" pitchFamily="34" charset="-122"/>
                 <a:cs typeface="IBM Plex Sans" pitchFamily="34" charset="-120"/>
               </a:rPr>
-              <a:t> web map of 200 test photos with live routes; Gradio app runs the model on an upload in 16 s</a:t>
+              <a:t> web map of 200 test photos with live routes; Gradio app runs the model on an upload in 30 s</a:t>
             </a:r>
             <a:endParaRPr lang="en-US" sz="1400" dirty="0"/>
           </a:p>
@@ -6504,7 +6544,7 @@
                 <a:ea typeface="IBM Plex Sans" pitchFamily="34" charset="-122"/>
                 <a:cs typeface="IBM Plex Sans" pitchFamily="34" charset="-120"/>
               </a:rPr>
-              <a:t>Tried and dropped:</a:t>
+              <a:t>Tried 36 ideas:</a:t>
             </a:r>
             <a:r>
               <a:rPr lang="en-US" sz="1500" dirty="0">
@@ -6515,7 +6555,7 @@
                 <a:ea typeface="IBM Plex Sans" pitchFamily="34" charset="-122"/>
                 <a:cs typeface="IBM Plex Sans" pitchFamily="34" charset="-120"/>
               </a:rPr>
-              <a:t> test-time flips (−.017 with their own tuning), 10 instead of 5 labels (no gain), smoothing.</a:t>
+              <a:t> kept a shorter schedule, weight averaging, an edge-aware decode and SAM (.472 → .507); the rest lost.</a:t>
             </a:r>
             <a:endParaRPr lang="en-US" sz="1500" dirty="0"/>
           </a:p>

</xml_diff>

<commit_message>
slides: live upload 17 s (measured on a Kaggle T4 with SAM on the GPU, peak 12.3 GB)
</commit_message>
<xml_diff>
--- a/slides/20260876_MarlenMelis_slides.pptx
+++ b/slides/20260876_MarlenMelis_slides.pptx
@@ -948,7 +948,7 @@
           <a:p>
             <a:r>
               <a:rPr lang="en-US" dirty="0"/>
-              <a:t>Track B is the system around the map. The router finds the cheapest way from the entry point to every house: truck on clear roads, then a boat across water, then on foot — with vehicle widths, parked cars and tree canopy taken into account. Left is the predicted map, middle the same street routed on the human labels — the same house needs a boat on both. Right, the hurricane-Michael canal: truck to the canal, boat across, walk to the house. Against the labelled map the router finds the houses that are cut off by road with F1 .752 on the full test; the better map did not change routing measurably. And it says how sure it is: houses marked "confident: truck" were all right; "check first" 79 percent. Everything runs in a web map of all 200 test photos, and a Gradio app runs the model live on an uploaded photo in 30 seconds. [Live demo here if there is time.]</a:t>
+              <a:t>Track B is the system around the map. The router finds the cheapest way from the entry point to every house: truck on clear roads, then a boat across water, then on foot — with vehicle widths, parked cars and tree canopy taken into account. Left is the predicted map, middle the same street routed on the human labels — the same house needs a boat on both. Right, the hurricane-Michael canal: truck to the canal, boat across, walk to the house. Against the labelled map the router finds the houses that are cut off by road with F1 .752 on the full test; the better map did not change routing measurably. And it says how sure it is: houses marked "confident: truck" were all right; "check first" 79 percent. Everything runs in a web map of all 200 test photos, and a Gradio app runs the model live on an uploaded photo in 17 seconds. [Live demo here if there is time.]</a:t>
             </a:r>
             <a:endParaRPr lang="en-US" dirty="0"/>
           </a:p>
@@ -6155,7 +6155,7 @@
                 <a:ea typeface="IBM Plex Sans" pitchFamily="34" charset="-122"/>
                 <a:cs typeface="IBM Plex Sans" pitchFamily="34" charset="-120"/>
               </a:rPr>
-              <a:t> web map of 200 test photos with live routes; Gradio app runs the model on an upload in 30 s</a:t>
+              <a:t> web map of 200 test photos with live routes; Gradio app runs the model on an upload in 17 s</a:t>
             </a:r>
             <a:endParaRPr lang="en-US" sz="1400" dirty="0"/>
           </a:p>

</xml_diff>